<commit_message>
feat: update Holiday Camp slide builders and decks
</commit_message>
<xml_diff>
--- a/Schools_ML_Track/camp_2026/slides/DA/DA01.pptx
+++ b/Schools_ML_Track/camp_2026/slides/DA/DA01.pptx
@@ -128,7 +128,7 @@
   <p:extLst>
     <p:ext uri="{521415D9-36F7-43E2-AB2F-B90AF26B5E84}">
       <p14:sectionLst xmlns:p14="http://schemas.microsoft.com/office/powerpoint/2010/main">
-        <p14:section name="Opening" id="{228dd0c9-1ecd-2bb9-2e8c-bdaa7a814bb0}">
+        <p14:section name="Opening" id="{d7c43e61-c1d7-0c5e-d0fa-9112e94352f7}">
           <p14:sldIdLst>
             <p14:sldId id="256"/>
             <p14:sldId id="257"/>
@@ -139,7 +139,7 @@
             <p14:sldId id="262"/>
           </p14:sldIdLst>
         </p14:section>
-        <p14:section name="Block A" id="{fcc4db0d-c20a-8ac1-e523-de62d3632fd5}">
+        <p14:section name="Block A" id="{162458a0-6b8d-0455-2254-89536e3201b1}">
           <p14:sldIdLst>
             <p14:sldId id="263"/>
             <p14:sldId id="264"/>
@@ -149,15 +149,15 @@
             <p14:sldId id="269"/>
           </p14:sldIdLst>
         </p14:section>
-        <p14:section name="Break" id="{2856df0e-936b-370b-4c6d-2d1d8c3c109f}">
+        <p14:section name="Break" id="{0d84829b-ec9a-7ba1-41c5-7681aab90b99}">
           <p14:sldIdLst>
             <p14:sldId id="267"/>
           </p14:sldIdLst>
         </p14:section>
-        <p14:section name="Block A" id="{4bf799e6-37fd-1a0a-51be-8be8c686436e}">
+        <p14:section name="Block A" id="{b1eb2326-5620-4609-0f9b-58b656afab8f}">
           <p14:sldIdLst/>
         </p14:section>
-        <p14:section name="Block B" id="{69aea998-fb16-67b6-a7d4-331a453b463f}">
+        <p14:section name="Block B" id="{3a1941d3-e2f5-2418-1e58-e500a3ecbe66}">
           <p14:sldIdLst>
             <p14:sldId id="270"/>
             <p14:sldId id="271"/>
@@ -166,7 +166,7 @@
             <p14:sldId id="274"/>
           </p14:sldIdLst>
         </p14:section>
-        <p14:section name="Make and close" id="{dfed4768-1653-5a98-7502-39500792ea3e}">
+        <p14:section name="Make and close" id="{8952d309-29b3-507e-be7f-67ed123f8b64}">
           <p14:sldIdLst>
             <p14:sldId id="275"/>
             <p14:sldId id="276"/>

</xml_diff>

<commit_message>
feat: refresh Holiday Camp slide decks
</commit_message>
<xml_diff>
--- a/Schools_ML_Track/camp_2026/slides/DA/DA01.pptx
+++ b/Schools_ML_Track/camp_2026/slides/DA/DA01.pptx
@@ -128,7 +128,7 @@
   <p:extLst>
     <p:ext uri="{521415D9-36F7-43E2-AB2F-B90AF26B5E84}">
       <p14:sectionLst xmlns:p14="http://schemas.microsoft.com/office/powerpoint/2010/main">
-        <p14:section name="Opening" id="{d7c43e61-c1d7-0c5e-d0fa-9112e94352f7}">
+        <p14:section name="Opening" id="{61c6ab5b-0c7a-76a9-f0a7-e79de9554b1f}">
           <p14:sldIdLst>
             <p14:sldId id="256"/>
             <p14:sldId id="257"/>
@@ -139,7 +139,7 @@
             <p14:sldId id="262"/>
           </p14:sldIdLst>
         </p14:section>
-        <p14:section name="Block A" id="{162458a0-6b8d-0455-2254-89536e3201b1}">
+        <p14:section name="Block A" id="{cb905783-c26b-b8fc-455d-9f5ee3fab9d2}">
           <p14:sldIdLst>
             <p14:sldId id="263"/>
             <p14:sldId id="264"/>
@@ -149,15 +149,15 @@
             <p14:sldId id="269"/>
           </p14:sldIdLst>
         </p14:section>
-        <p14:section name="Break" id="{0d84829b-ec9a-7ba1-41c5-7681aab90b99}">
+        <p14:section name="Break" id="{067b1449-a0b8-d042-7d3a-4aa172410546}">
           <p14:sldIdLst>
             <p14:sldId id="267"/>
           </p14:sldIdLst>
         </p14:section>
-        <p14:section name="Block A" id="{b1eb2326-5620-4609-0f9b-58b656afab8f}">
+        <p14:section name="Block A" id="{496da79f-2db4-5e8f-43d5-7a3067f4b668}">
           <p14:sldIdLst/>
         </p14:section>
-        <p14:section name="Block B" id="{3a1941d3-e2f5-2418-1e58-e500a3ecbe66}">
+        <p14:section name="Block B" id="{d9a3f16e-803a-6af6-5583-e5a2cd170cf7}">
           <p14:sldIdLst>
             <p14:sldId id="270"/>
             <p14:sldId id="271"/>
@@ -166,7 +166,7 @@
             <p14:sldId id="274"/>
           </p14:sldIdLst>
         </p14:section>
-        <p14:section name="Make and close" id="{8952d309-29b3-507e-be7f-67ed123f8b64}">
+        <p14:section name="Make and close" id="{d19f56c5-768f-d4e5-766a-3fb46419c96f}">
           <p14:sldIdLst>
             <p14:sldId id="275"/>
             <p14:sldId id="276"/>
@@ -3197,7 +3197,24 @@
                 <a:ea typeface="Lato" pitchFamily="34" charset="-122"/>
                 <a:cs typeface="Lato" pitchFamily="34" charset="-120"/>
               </a:rPr>
-              <a:t>Open a notebook and read your first table</a:t>
+              <a:t>Open a notebook and</a:t>
+            </a:r>
+            <a:endParaRPr lang="en-US" sz="5600" dirty="0"/>
+          </a:p>
+          <a:p>
+            <a:pPr algn="l" indent="0" marL="0">
+              <a:buNone/>
+            </a:pPr>
+            <a:r>
+              <a:rPr lang="en-US" sz="5600" b="1" dirty="0">
+                <a:solidFill>
+                  <a:srgbClr val="FFFFFF"/>
+                </a:solidFill>
+                <a:latin typeface="Lato" pitchFamily="34" charset="0"/>
+                <a:ea typeface="Lato" pitchFamily="34" charset="-122"/>
+                <a:cs typeface="Lato" pitchFamily="34" charset="-120"/>
+              </a:rPr>
+              <a:t>read your first table</a:t>
             </a:r>
             <a:endParaRPr lang="en-US" sz="5600" dirty="0"/>
           </a:p>
@@ -6022,15 +6039,15 @@
           <a:p>
             <a:pPr algn="l" indent="0" marL="0">
               <a:lnSpc>
-                <a:spcPts val="3600"/>
+                <a:spcPts val="3360"/>
               </a:lnSpc>
               <a:spcAft>
-                <a:spcPts val="2520"/>
+                <a:spcPts val="2020"/>
               </a:spcAft>
               <a:buNone/>
             </a:pPr>
             <a:r>
-              <a:rPr lang="en-US" sz="3000" dirty="0">
+              <a:rPr lang="en-US" sz="2800" dirty="0">
                 <a:solidFill>
                   <a:srgbClr val="111111"/>
                 </a:solidFill>
@@ -6038,22 +6055,22 @@
                 <a:ea typeface="Lato" pitchFamily="34" charset="-122"/>
                 <a:cs typeface="Lato" pitchFamily="34" charset="-120"/>
               </a:rPr>
-              <a:t>In a new code cell show your nickname and the result of 7 + 4. Then show the first three rows of the shop table with head(3). Save the notebook as DA01.ipynb, close it and open it again.</a:t>
-            </a:r>
-            <a:endParaRPr lang="en-US" sz="3000" dirty="0"/>
+              <a:t>In a new code cell show your nickname and the result of 7 + 4.</a:t>
+            </a:r>
+            <a:endParaRPr lang="en-US" sz="2800" dirty="0"/>
           </a:p>
           <a:p>
             <a:pPr algn="l" indent="0" marL="0">
               <a:lnSpc>
-                <a:spcPts val="3600"/>
+                <a:spcPts val="3360"/>
               </a:lnSpc>
               <a:spcAft>
-                <a:spcPts val="2520"/>
+                <a:spcPts val="2020"/>
               </a:spcAft>
               <a:buNone/>
             </a:pPr>
             <a:r>
-              <a:rPr lang="en-US" sz="3000" dirty="0">
+              <a:rPr lang="en-US" sz="2800" dirty="0">
                 <a:solidFill>
                   <a:srgbClr val="111111"/>
                 </a:solidFill>
@@ -6061,9 +6078,55 @@
                 <a:ea typeface="Lato" pitchFamily="34" charset="-122"/>
                 <a:cs typeface="Lato" pitchFamily="34" charset="-120"/>
               </a:rPr>
-              <a:t>Save it as DA01. Write two sentences: what you changed and how you checked it.</a:t>
-            </a:r>
-            <a:endParaRPr lang="en-US" sz="3000" dirty="0"/>
+              <a:t>Then show the first three rows of the shop table with head(3).</a:t>
+            </a:r>
+            <a:endParaRPr lang="en-US" sz="2800" dirty="0"/>
+          </a:p>
+          <a:p>
+            <a:pPr algn="l" indent="0" marL="0">
+              <a:lnSpc>
+                <a:spcPts val="3360"/>
+              </a:lnSpc>
+              <a:spcAft>
+                <a:spcPts val="2020"/>
+              </a:spcAft>
+              <a:buNone/>
+            </a:pPr>
+            <a:r>
+              <a:rPr lang="en-US" sz="2800" dirty="0">
+                <a:solidFill>
+                  <a:srgbClr val="111111"/>
+                </a:solidFill>
+                <a:latin typeface="Lato" pitchFamily="34" charset="0"/>
+                <a:ea typeface="Lato" pitchFamily="34" charset="-122"/>
+                <a:cs typeface="Lato" pitchFamily="34" charset="-120"/>
+              </a:rPr>
+              <a:t>Save the notebook as DA01.ipynb, close it and open it again.</a:t>
+            </a:r>
+            <a:endParaRPr lang="en-US" sz="2800" dirty="0"/>
+          </a:p>
+          <a:p>
+            <a:pPr algn="l" indent="0" marL="0">
+              <a:lnSpc>
+                <a:spcPts val="3360"/>
+              </a:lnSpc>
+              <a:spcAft>
+                <a:spcPts val="2020"/>
+              </a:spcAft>
+              <a:buNone/>
+            </a:pPr>
+            <a:r>
+              <a:rPr lang="en-US" sz="2800" dirty="0">
+                <a:solidFill>
+                  <a:srgbClr val="111111"/>
+                </a:solidFill>
+                <a:latin typeface="Lato" pitchFamily="34" charset="0"/>
+                <a:ea typeface="Lato" pitchFamily="34" charset="-122"/>
+                <a:cs typeface="Lato" pitchFamily="34" charset="-120"/>
+              </a:rPr>
+              <a:t>Write two sentences: what you changed and how you checked it.</a:t>
+            </a:r>
+            <a:endParaRPr lang="en-US" sz="2800" dirty="0"/>
           </a:p>
         </p:txBody>
       </p:sp>

</xml_diff>